<commit_message>
Added lectures 3 and 4.
</commit_message>
<xml_diff>
--- a/Lectures/Lecture2.pptx
+++ b/Lectures/Lecture2.pptx
@@ -299,7 +299,7 @@
             <a:fld id="{767E4735-A5D0-044D-BE7E-3A4B3C0A561F}" type="datetimeFigureOut">
               <a:rPr lang="en-US" smtClean="0"/>
               <a:pPr/>
-              <a:t>10/15/19</a:t>
+              <a:t>10/29/19</a:t>
             </a:fld>
             <a:endParaRPr lang="en-US"/>
           </a:p>
@@ -7907,19 +7907,33 @@
         </p:nvSpPr>
         <p:spPr>
           <a:xfrm>
-            <a:off x="685800" y="1447800"/>
-            <a:ext cx="7772400" cy="1143000"/>
+            <a:off x="685800" y="381000"/>
+            <a:ext cx="7772400" cy="2209800"/>
           </a:xfrm>
         </p:spPr>
         <p:txBody>
           <a:bodyPr>
-            <a:normAutofit fontScale="90000"/>
+            <a:normAutofit/>
           </a:bodyPr>
           <a:lstStyle/>
           <a:p>
             <a:r>
               <a:rPr lang="en-US" dirty="0"/>
-              <a:t>Neural Networks. Backprop. Modular Design.</a:t>
+              <a:t>Neural Networks. </a:t>
+            </a:r>
+            <a:br>
+              <a:rPr lang="en-US" dirty="0"/>
+            </a:br>
+            <a:r>
+              <a:rPr lang="en-US" dirty="0"/>
+              <a:t>Backprop. </a:t>
+            </a:r>
+            <a:br>
+              <a:rPr lang="en-US" dirty="0"/>
+            </a:br>
+            <a:r>
+              <a:rPr lang="en-US"/>
+              <a:t>Modular Design</a:t>
             </a:r>
             <a:endParaRPr lang="en-US" sz="3200" dirty="0"/>
           </a:p>
@@ -9689,6 +9703,134 @@
   <p:clrMapOvr>
     <a:masterClrMapping/>
   </p:clrMapOvr>
+  <p:timing>
+    <p:tnLst>
+      <p:par>
+        <p:cTn id="1" dur="indefinite" restart="never" nodeType="tmRoot">
+          <p:childTnLst>
+            <p:seq concurrent="1" nextAc="seek">
+              <p:cTn id="2" dur="indefinite" nodeType="mainSeq">
+                <p:childTnLst>
+                  <p:par>
+                    <p:cTn id="3" fill="hold">
+                      <p:stCondLst>
+                        <p:cond delay="indefinite"/>
+                      </p:stCondLst>
+                      <p:childTnLst>
+                        <p:par>
+                          <p:cTn id="4" fill="hold">
+                            <p:stCondLst>
+                              <p:cond delay="0"/>
+                            </p:stCondLst>
+                            <p:childTnLst>
+                              <p:par>
+                                <p:cTn id="5" presetID="1" presetClass="entr" presetSubtype="0" fill="hold" nodeType="clickEffect">
+                                  <p:stCondLst>
+                                    <p:cond delay="0"/>
+                                  </p:stCondLst>
+                                  <p:childTnLst>
+                                    <p:set>
+                                      <p:cBhvr>
+                                        <p:cTn id="6" dur="1" fill="hold">
+                                          <p:stCondLst>
+                                            <p:cond delay="0"/>
+                                          </p:stCondLst>
+                                        </p:cTn>
+                                        <p:tgtEl>
+                                          <p:spTgt spid="3">
+                                            <p:txEl>
+                                              <p:pRg st="1" end="1"/>
+                                            </p:txEl>
+                                          </p:spTgt>
+                                        </p:tgtEl>
+                                        <p:attrNameLst>
+                                          <p:attrName>style.visibility</p:attrName>
+                                        </p:attrNameLst>
+                                      </p:cBhvr>
+                                      <p:to>
+                                        <p:strVal val="visible"/>
+                                      </p:to>
+                                    </p:set>
+                                  </p:childTnLst>
+                                </p:cTn>
+                              </p:par>
+                            </p:childTnLst>
+                          </p:cTn>
+                        </p:par>
+                      </p:childTnLst>
+                    </p:cTn>
+                  </p:par>
+                  <p:par>
+                    <p:cTn id="7" fill="hold">
+                      <p:stCondLst>
+                        <p:cond delay="indefinite"/>
+                      </p:stCondLst>
+                      <p:childTnLst>
+                        <p:par>
+                          <p:cTn id="8" fill="hold">
+                            <p:stCondLst>
+                              <p:cond delay="0"/>
+                            </p:stCondLst>
+                            <p:childTnLst>
+                              <p:par>
+                                <p:cTn id="9" presetID="1" presetClass="entr" presetSubtype="0" fill="hold" nodeType="clickEffect">
+                                  <p:stCondLst>
+                                    <p:cond delay="0"/>
+                                  </p:stCondLst>
+                                  <p:childTnLst>
+                                    <p:set>
+                                      <p:cBhvr>
+                                        <p:cTn id="10" dur="1" fill="hold">
+                                          <p:stCondLst>
+                                            <p:cond delay="0"/>
+                                          </p:stCondLst>
+                                        </p:cTn>
+                                        <p:tgtEl>
+                                          <p:spTgt spid="3">
+                                            <p:txEl>
+                                              <p:pRg st="2" end="2"/>
+                                            </p:txEl>
+                                          </p:spTgt>
+                                        </p:tgtEl>
+                                        <p:attrNameLst>
+                                          <p:attrName>style.visibility</p:attrName>
+                                        </p:attrNameLst>
+                                      </p:cBhvr>
+                                      <p:to>
+                                        <p:strVal val="visible"/>
+                                      </p:to>
+                                    </p:set>
+                                  </p:childTnLst>
+                                </p:cTn>
+                              </p:par>
+                            </p:childTnLst>
+                          </p:cTn>
+                        </p:par>
+                      </p:childTnLst>
+                    </p:cTn>
+                  </p:par>
+                </p:childTnLst>
+              </p:cTn>
+              <p:prevCondLst>
+                <p:cond evt="onPrev" delay="0">
+                  <p:tgtEl>
+                    <p:sldTgt/>
+                  </p:tgtEl>
+                </p:cond>
+              </p:prevCondLst>
+              <p:nextCondLst>
+                <p:cond evt="onNext" delay="0">
+                  <p:tgtEl>
+                    <p:sldTgt/>
+                  </p:tgtEl>
+                </p:cond>
+              </p:nextCondLst>
+            </p:seq>
+          </p:childTnLst>
+        </p:cTn>
+      </p:par>
+    </p:tnLst>
+  </p:timing>
 </p:sld>
 </file>
 
@@ -9926,6 +10068,134 @@
   <p:clrMapOvr>
     <a:masterClrMapping/>
   </p:clrMapOvr>
+  <p:timing>
+    <p:tnLst>
+      <p:par>
+        <p:cTn id="1" dur="indefinite" restart="never" nodeType="tmRoot">
+          <p:childTnLst>
+            <p:seq concurrent="1" nextAc="seek">
+              <p:cTn id="2" dur="indefinite" nodeType="mainSeq">
+                <p:childTnLst>
+                  <p:par>
+                    <p:cTn id="3" fill="hold">
+                      <p:stCondLst>
+                        <p:cond delay="indefinite"/>
+                      </p:stCondLst>
+                      <p:childTnLst>
+                        <p:par>
+                          <p:cTn id="4" fill="hold">
+                            <p:stCondLst>
+                              <p:cond delay="0"/>
+                            </p:stCondLst>
+                            <p:childTnLst>
+                              <p:par>
+                                <p:cTn id="5" presetID="1" presetClass="entr" presetSubtype="0" fill="hold" nodeType="clickEffect">
+                                  <p:stCondLst>
+                                    <p:cond delay="0"/>
+                                  </p:stCondLst>
+                                  <p:childTnLst>
+                                    <p:set>
+                                      <p:cBhvr>
+                                        <p:cTn id="6" dur="1" fill="hold">
+                                          <p:stCondLst>
+                                            <p:cond delay="0"/>
+                                          </p:stCondLst>
+                                        </p:cTn>
+                                        <p:tgtEl>
+                                          <p:spTgt spid="3">
+                                            <p:txEl>
+                                              <p:pRg st="2" end="2"/>
+                                            </p:txEl>
+                                          </p:spTgt>
+                                        </p:tgtEl>
+                                        <p:attrNameLst>
+                                          <p:attrName>style.visibility</p:attrName>
+                                        </p:attrNameLst>
+                                      </p:cBhvr>
+                                      <p:to>
+                                        <p:strVal val="visible"/>
+                                      </p:to>
+                                    </p:set>
+                                  </p:childTnLst>
+                                </p:cTn>
+                              </p:par>
+                            </p:childTnLst>
+                          </p:cTn>
+                        </p:par>
+                      </p:childTnLst>
+                    </p:cTn>
+                  </p:par>
+                  <p:par>
+                    <p:cTn id="7" fill="hold">
+                      <p:stCondLst>
+                        <p:cond delay="indefinite"/>
+                      </p:stCondLst>
+                      <p:childTnLst>
+                        <p:par>
+                          <p:cTn id="8" fill="hold">
+                            <p:stCondLst>
+                              <p:cond delay="0"/>
+                            </p:stCondLst>
+                            <p:childTnLst>
+                              <p:par>
+                                <p:cTn id="9" presetID="1" presetClass="entr" presetSubtype="0" fill="hold" nodeType="clickEffect">
+                                  <p:stCondLst>
+                                    <p:cond delay="0"/>
+                                  </p:stCondLst>
+                                  <p:childTnLst>
+                                    <p:set>
+                                      <p:cBhvr>
+                                        <p:cTn id="10" dur="1" fill="hold">
+                                          <p:stCondLst>
+                                            <p:cond delay="0"/>
+                                          </p:stCondLst>
+                                        </p:cTn>
+                                        <p:tgtEl>
+                                          <p:spTgt spid="3">
+                                            <p:txEl>
+                                              <p:pRg st="4" end="4"/>
+                                            </p:txEl>
+                                          </p:spTgt>
+                                        </p:tgtEl>
+                                        <p:attrNameLst>
+                                          <p:attrName>style.visibility</p:attrName>
+                                        </p:attrNameLst>
+                                      </p:cBhvr>
+                                      <p:to>
+                                        <p:strVal val="visible"/>
+                                      </p:to>
+                                    </p:set>
+                                  </p:childTnLst>
+                                </p:cTn>
+                              </p:par>
+                            </p:childTnLst>
+                          </p:cTn>
+                        </p:par>
+                      </p:childTnLst>
+                    </p:cTn>
+                  </p:par>
+                </p:childTnLst>
+              </p:cTn>
+              <p:prevCondLst>
+                <p:cond evt="onPrev" delay="0">
+                  <p:tgtEl>
+                    <p:sldTgt/>
+                  </p:tgtEl>
+                </p:cond>
+              </p:prevCondLst>
+              <p:nextCondLst>
+                <p:cond evt="onNext" delay="0">
+                  <p:tgtEl>
+                    <p:sldTgt/>
+                  </p:tgtEl>
+                </p:cond>
+              </p:nextCondLst>
+            </p:seq>
+          </p:childTnLst>
+        </p:cTn>
+      </p:par>
+    </p:tnLst>
+  </p:timing>
 </p:sld>
 </file>
 
@@ -10075,6 +10345,134 @@
   <p:clrMapOvr>
     <a:masterClrMapping/>
   </p:clrMapOvr>
+  <p:timing>
+    <p:tnLst>
+      <p:par>
+        <p:cTn id="1" dur="indefinite" restart="never" nodeType="tmRoot">
+          <p:childTnLst>
+            <p:seq concurrent="1" nextAc="seek">
+              <p:cTn id="2" dur="indefinite" nodeType="mainSeq">
+                <p:childTnLst>
+                  <p:par>
+                    <p:cTn id="3" fill="hold">
+                      <p:stCondLst>
+                        <p:cond delay="indefinite"/>
+                      </p:stCondLst>
+                      <p:childTnLst>
+                        <p:par>
+                          <p:cTn id="4" fill="hold">
+                            <p:stCondLst>
+                              <p:cond delay="0"/>
+                            </p:stCondLst>
+                            <p:childTnLst>
+                              <p:par>
+                                <p:cTn id="5" presetID="1" presetClass="entr" presetSubtype="0" fill="hold" nodeType="clickEffect">
+                                  <p:stCondLst>
+                                    <p:cond delay="0"/>
+                                  </p:stCondLst>
+                                  <p:childTnLst>
+                                    <p:set>
+                                      <p:cBhvr>
+                                        <p:cTn id="6" dur="1" fill="hold">
+                                          <p:stCondLst>
+                                            <p:cond delay="0"/>
+                                          </p:stCondLst>
+                                        </p:cTn>
+                                        <p:tgtEl>
+                                          <p:spTgt spid="3">
+                                            <p:txEl>
+                                              <p:pRg st="1" end="1"/>
+                                            </p:txEl>
+                                          </p:spTgt>
+                                        </p:tgtEl>
+                                        <p:attrNameLst>
+                                          <p:attrName>style.visibility</p:attrName>
+                                        </p:attrNameLst>
+                                      </p:cBhvr>
+                                      <p:to>
+                                        <p:strVal val="visible"/>
+                                      </p:to>
+                                    </p:set>
+                                  </p:childTnLst>
+                                </p:cTn>
+                              </p:par>
+                            </p:childTnLst>
+                          </p:cTn>
+                        </p:par>
+                      </p:childTnLst>
+                    </p:cTn>
+                  </p:par>
+                  <p:par>
+                    <p:cTn id="7" fill="hold">
+                      <p:stCondLst>
+                        <p:cond delay="indefinite"/>
+                      </p:stCondLst>
+                      <p:childTnLst>
+                        <p:par>
+                          <p:cTn id="8" fill="hold">
+                            <p:stCondLst>
+                              <p:cond delay="0"/>
+                            </p:stCondLst>
+                            <p:childTnLst>
+                              <p:par>
+                                <p:cTn id="9" presetID="1" presetClass="entr" presetSubtype="0" fill="hold" nodeType="clickEffect">
+                                  <p:stCondLst>
+                                    <p:cond delay="0"/>
+                                  </p:stCondLst>
+                                  <p:childTnLst>
+                                    <p:set>
+                                      <p:cBhvr>
+                                        <p:cTn id="10" dur="1" fill="hold">
+                                          <p:stCondLst>
+                                            <p:cond delay="0"/>
+                                          </p:stCondLst>
+                                        </p:cTn>
+                                        <p:tgtEl>
+                                          <p:spTgt spid="3">
+                                            <p:txEl>
+                                              <p:pRg st="2" end="2"/>
+                                            </p:txEl>
+                                          </p:spTgt>
+                                        </p:tgtEl>
+                                        <p:attrNameLst>
+                                          <p:attrName>style.visibility</p:attrName>
+                                        </p:attrNameLst>
+                                      </p:cBhvr>
+                                      <p:to>
+                                        <p:strVal val="visible"/>
+                                      </p:to>
+                                    </p:set>
+                                  </p:childTnLst>
+                                </p:cTn>
+                              </p:par>
+                            </p:childTnLst>
+                          </p:cTn>
+                        </p:par>
+                      </p:childTnLst>
+                    </p:cTn>
+                  </p:par>
+                </p:childTnLst>
+              </p:cTn>
+              <p:prevCondLst>
+                <p:cond evt="onPrev" delay="0">
+                  <p:tgtEl>
+                    <p:sldTgt/>
+                  </p:tgtEl>
+                </p:cond>
+              </p:prevCondLst>
+              <p:nextCondLst>
+                <p:cond evt="onNext" delay="0">
+                  <p:tgtEl>
+                    <p:sldTgt/>
+                  </p:tgtEl>
+                </p:cond>
+              </p:nextCondLst>
+            </p:seq>
+          </p:childTnLst>
+        </p:cTn>
+      </p:par>
+    </p:tnLst>
+  </p:timing>
 </p:sld>
 </file>
 
@@ -10138,7 +10536,7 @@
         <p:spPr>
           <a:xfrm>
             <a:off x="457200" y="1980310"/>
-            <a:ext cx="5023474" cy="1846243"/>
+            <a:ext cx="5023474" cy="2027202"/>
           </a:xfrm>
           <a:prstGeom prst="rect">
             <a:avLst/>
@@ -10288,6 +10686,112 @@
   <p:clrMapOvr>
     <a:masterClrMapping/>
   </p:clrMapOvr>
+  <p:timing>
+    <p:tnLst>
+      <p:par>
+        <p:cTn id="1" dur="indefinite" restart="never" nodeType="tmRoot">
+          <p:childTnLst>
+            <p:seq concurrent="1" nextAc="seek">
+              <p:cTn id="2" dur="indefinite" nodeType="mainSeq">
+                <p:childTnLst>
+                  <p:par>
+                    <p:cTn id="3" fill="hold">
+                      <p:stCondLst>
+                        <p:cond delay="indefinite"/>
+                      </p:stCondLst>
+                      <p:childTnLst>
+                        <p:par>
+                          <p:cTn id="4" fill="hold">
+                            <p:stCondLst>
+                              <p:cond delay="0"/>
+                            </p:stCondLst>
+                            <p:childTnLst>
+                              <p:par>
+                                <p:cTn id="5" presetID="1" presetClass="entr" presetSubtype="0" fill="hold" nodeType="clickEffect">
+                                  <p:stCondLst>
+                                    <p:cond delay="0"/>
+                                  </p:stCondLst>
+                                  <p:childTnLst>
+                                    <p:set>
+                                      <p:cBhvr>
+                                        <p:cTn id="6" dur="1" fill="hold">
+                                          <p:stCondLst>
+                                            <p:cond delay="0"/>
+                                          </p:stCondLst>
+                                        </p:cTn>
+                                        <p:tgtEl>
+                                          <p:spTgt spid="1168">
+                                            <p:txEl>
+                                              <p:pRg st="4" end="4"/>
+                                            </p:txEl>
+                                          </p:spTgt>
+                                        </p:tgtEl>
+                                        <p:attrNameLst>
+                                          <p:attrName>style.visibility</p:attrName>
+                                        </p:attrNameLst>
+                                      </p:cBhvr>
+                                      <p:to>
+                                        <p:strVal val="visible"/>
+                                      </p:to>
+                                    </p:set>
+                                  </p:childTnLst>
+                                </p:cTn>
+                              </p:par>
+                              <p:par>
+                                <p:cTn id="7" presetID="1" presetClass="entr" presetSubtype="0" fill="hold" nodeType="withEffect">
+                                  <p:stCondLst>
+                                    <p:cond delay="0"/>
+                                  </p:stCondLst>
+                                  <p:childTnLst>
+                                    <p:set>
+                                      <p:cBhvr>
+                                        <p:cTn id="8" dur="1" fill="hold">
+                                          <p:stCondLst>
+                                            <p:cond delay="0"/>
+                                          </p:stCondLst>
+                                        </p:cTn>
+                                        <p:tgtEl>
+                                          <p:spTgt spid="19"/>
+                                        </p:tgtEl>
+                                        <p:attrNameLst>
+                                          <p:attrName>style.visibility</p:attrName>
+                                        </p:attrNameLst>
+                                      </p:cBhvr>
+                                      <p:to>
+                                        <p:strVal val="visible"/>
+                                      </p:to>
+                                    </p:set>
+                                  </p:childTnLst>
+                                </p:cTn>
+                              </p:par>
+                            </p:childTnLst>
+                          </p:cTn>
+                        </p:par>
+                      </p:childTnLst>
+                    </p:cTn>
+                  </p:par>
+                </p:childTnLst>
+              </p:cTn>
+              <p:prevCondLst>
+                <p:cond evt="onPrev" delay="0">
+                  <p:tgtEl>
+                    <p:sldTgt/>
+                  </p:tgtEl>
+                </p:cond>
+              </p:prevCondLst>
+              <p:nextCondLst>
+                <p:cond evt="onNext" delay="0">
+                  <p:tgtEl>
+                    <p:sldTgt/>
+                  </p:tgtEl>
+                </p:cond>
+              </p:nextCondLst>
+            </p:seq>
+          </p:childTnLst>
+        </p:cTn>
+      </p:par>
+    </p:tnLst>
+  </p:timing>
 </p:sld>
 </file>
 
@@ -17029,7 +17533,7 @@
             <a:pPr lvl="1"/>
             <a:r>
               <a:rPr lang="en-US" dirty="0"/>
-              <a:t>Find best g in model class. </a:t>
+              <a:t>Find best g in model class</a:t>
             </a:r>
           </a:p>
         </p:txBody>
@@ -17044,6 +17548,387 @@
   <p:clrMapOvr>
     <a:masterClrMapping/>
   </p:clrMapOvr>
+  <p:timing>
+    <p:tnLst>
+      <p:par>
+        <p:cTn id="1" dur="indefinite" restart="never" nodeType="tmRoot">
+          <p:childTnLst>
+            <p:seq concurrent="1" nextAc="seek">
+              <p:cTn id="2" dur="indefinite" nodeType="mainSeq">
+                <p:childTnLst>
+                  <p:par>
+                    <p:cTn id="3" fill="hold">
+                      <p:stCondLst>
+                        <p:cond delay="indefinite"/>
+                      </p:stCondLst>
+                      <p:childTnLst>
+                        <p:par>
+                          <p:cTn id="4" fill="hold">
+                            <p:stCondLst>
+                              <p:cond delay="0"/>
+                            </p:stCondLst>
+                            <p:childTnLst>
+                              <p:par>
+                                <p:cTn id="5" presetID="1" presetClass="entr" presetSubtype="0" fill="hold" nodeType="clickEffect">
+                                  <p:stCondLst>
+                                    <p:cond delay="0"/>
+                                  </p:stCondLst>
+                                  <p:childTnLst>
+                                    <p:set>
+                                      <p:cBhvr>
+                                        <p:cTn id="6" dur="1" fill="hold">
+                                          <p:stCondLst>
+                                            <p:cond delay="0"/>
+                                          </p:stCondLst>
+                                        </p:cTn>
+                                        <p:tgtEl>
+                                          <p:spTgt spid="3">
+                                            <p:txEl>
+                                              <p:pRg st="4" end="4"/>
+                                            </p:txEl>
+                                          </p:spTgt>
+                                        </p:tgtEl>
+                                        <p:attrNameLst>
+                                          <p:attrName>style.visibility</p:attrName>
+                                        </p:attrNameLst>
+                                      </p:cBhvr>
+                                      <p:to>
+                                        <p:strVal val="visible"/>
+                                      </p:to>
+                                    </p:set>
+                                  </p:childTnLst>
+                                </p:cTn>
+                              </p:par>
+                              <p:par>
+                                <p:cTn id="7" presetID="1" presetClass="entr" presetSubtype="0" fill="hold" nodeType="withEffect">
+                                  <p:stCondLst>
+                                    <p:cond delay="0"/>
+                                  </p:stCondLst>
+                                  <p:childTnLst>
+                                    <p:set>
+                                      <p:cBhvr>
+                                        <p:cTn id="8" dur="1" fill="hold">
+                                          <p:stCondLst>
+                                            <p:cond delay="0"/>
+                                          </p:stCondLst>
+                                        </p:cTn>
+                                        <p:tgtEl>
+                                          <p:spTgt spid="3">
+                                            <p:txEl>
+                                              <p:pRg st="5" end="5"/>
+                                            </p:txEl>
+                                          </p:spTgt>
+                                        </p:tgtEl>
+                                        <p:attrNameLst>
+                                          <p:attrName>style.visibility</p:attrName>
+                                        </p:attrNameLst>
+                                      </p:cBhvr>
+                                      <p:to>
+                                        <p:strVal val="visible"/>
+                                      </p:to>
+                                    </p:set>
+                                  </p:childTnLst>
+                                </p:cTn>
+                              </p:par>
+                            </p:childTnLst>
+                          </p:cTn>
+                        </p:par>
+                      </p:childTnLst>
+                    </p:cTn>
+                  </p:par>
+                  <p:par>
+                    <p:cTn id="9" fill="hold">
+                      <p:stCondLst>
+                        <p:cond delay="indefinite"/>
+                      </p:stCondLst>
+                      <p:childTnLst>
+                        <p:par>
+                          <p:cTn id="10" fill="hold">
+                            <p:stCondLst>
+                              <p:cond delay="0"/>
+                            </p:stCondLst>
+                            <p:childTnLst>
+                              <p:par>
+                                <p:cTn id="11" presetID="1" presetClass="entr" presetSubtype="0" fill="hold" nodeType="clickEffect">
+                                  <p:stCondLst>
+                                    <p:cond delay="0"/>
+                                  </p:stCondLst>
+                                  <p:childTnLst>
+                                    <p:set>
+                                      <p:cBhvr>
+                                        <p:cTn id="12" dur="1" fill="hold">
+                                          <p:stCondLst>
+                                            <p:cond delay="0"/>
+                                          </p:stCondLst>
+                                        </p:cTn>
+                                        <p:tgtEl>
+                                          <p:spTgt spid="3">
+                                            <p:txEl>
+                                              <p:pRg st="7" end="7"/>
+                                            </p:txEl>
+                                          </p:spTgt>
+                                        </p:tgtEl>
+                                        <p:attrNameLst>
+                                          <p:attrName>style.visibility</p:attrName>
+                                        </p:attrNameLst>
+                                      </p:cBhvr>
+                                      <p:to>
+                                        <p:strVal val="visible"/>
+                                      </p:to>
+                                    </p:set>
+                                  </p:childTnLst>
+                                </p:cTn>
+                              </p:par>
+                              <p:par>
+                                <p:cTn id="13" presetID="1" presetClass="entr" presetSubtype="0" fill="hold" nodeType="withEffect">
+                                  <p:stCondLst>
+                                    <p:cond delay="0"/>
+                                  </p:stCondLst>
+                                  <p:childTnLst>
+                                    <p:set>
+                                      <p:cBhvr>
+                                        <p:cTn id="14" dur="1" fill="hold">
+                                          <p:stCondLst>
+                                            <p:cond delay="0"/>
+                                          </p:stCondLst>
+                                        </p:cTn>
+                                        <p:tgtEl>
+                                          <p:spTgt spid="3">
+                                            <p:txEl>
+                                              <p:pRg st="8" end="8"/>
+                                            </p:txEl>
+                                          </p:spTgt>
+                                        </p:tgtEl>
+                                        <p:attrNameLst>
+                                          <p:attrName>style.visibility</p:attrName>
+                                        </p:attrNameLst>
+                                      </p:cBhvr>
+                                      <p:to>
+                                        <p:strVal val="visible"/>
+                                      </p:to>
+                                    </p:set>
+                                  </p:childTnLst>
+                                </p:cTn>
+                              </p:par>
+                            </p:childTnLst>
+                          </p:cTn>
+                        </p:par>
+                      </p:childTnLst>
+                    </p:cTn>
+                  </p:par>
+                  <p:par>
+                    <p:cTn id="15" fill="hold">
+                      <p:stCondLst>
+                        <p:cond delay="indefinite"/>
+                      </p:stCondLst>
+                      <p:childTnLst>
+                        <p:par>
+                          <p:cTn id="16" fill="hold">
+                            <p:stCondLst>
+                              <p:cond delay="0"/>
+                            </p:stCondLst>
+                            <p:childTnLst>
+                              <p:par>
+                                <p:cTn id="17" presetID="1" presetClass="entr" presetSubtype="0" fill="hold" nodeType="clickEffect">
+                                  <p:stCondLst>
+                                    <p:cond delay="0"/>
+                                  </p:stCondLst>
+                                  <p:childTnLst>
+                                    <p:set>
+                                      <p:cBhvr>
+                                        <p:cTn id="18" dur="1" fill="hold">
+                                          <p:stCondLst>
+                                            <p:cond delay="0"/>
+                                          </p:stCondLst>
+                                        </p:cTn>
+                                        <p:tgtEl>
+                                          <p:spTgt spid="3">
+                                            <p:txEl>
+                                              <p:pRg st="10" end="10"/>
+                                            </p:txEl>
+                                          </p:spTgt>
+                                        </p:tgtEl>
+                                        <p:attrNameLst>
+                                          <p:attrName>style.visibility</p:attrName>
+                                        </p:attrNameLst>
+                                      </p:cBhvr>
+                                      <p:to>
+                                        <p:strVal val="visible"/>
+                                      </p:to>
+                                    </p:set>
+                                  </p:childTnLst>
+                                </p:cTn>
+                              </p:par>
+                              <p:par>
+                                <p:cTn id="19" presetID="1" presetClass="entr" presetSubtype="0" fill="hold" nodeType="withEffect">
+                                  <p:stCondLst>
+                                    <p:cond delay="0"/>
+                                  </p:stCondLst>
+                                  <p:childTnLst>
+                                    <p:set>
+                                      <p:cBhvr>
+                                        <p:cTn id="20" dur="1" fill="hold">
+                                          <p:stCondLst>
+                                            <p:cond delay="0"/>
+                                          </p:stCondLst>
+                                        </p:cTn>
+                                        <p:tgtEl>
+                                          <p:spTgt spid="3">
+                                            <p:txEl>
+                                              <p:pRg st="11" end="11"/>
+                                            </p:txEl>
+                                          </p:spTgt>
+                                        </p:tgtEl>
+                                        <p:attrNameLst>
+                                          <p:attrName>style.visibility</p:attrName>
+                                        </p:attrNameLst>
+                                      </p:cBhvr>
+                                      <p:to>
+                                        <p:strVal val="visible"/>
+                                      </p:to>
+                                    </p:set>
+                                  </p:childTnLst>
+                                </p:cTn>
+                              </p:par>
+                              <p:par>
+                                <p:cTn id="21" presetID="1" presetClass="entr" presetSubtype="0" fill="hold" nodeType="withEffect">
+                                  <p:stCondLst>
+                                    <p:cond delay="0"/>
+                                  </p:stCondLst>
+                                  <p:childTnLst>
+                                    <p:set>
+                                      <p:cBhvr>
+                                        <p:cTn id="22" dur="1" fill="hold">
+                                          <p:stCondLst>
+                                            <p:cond delay="0"/>
+                                          </p:stCondLst>
+                                        </p:cTn>
+                                        <p:tgtEl>
+                                          <p:spTgt spid="3">
+                                            <p:txEl>
+                                              <p:pRg st="12" end="12"/>
+                                            </p:txEl>
+                                          </p:spTgt>
+                                        </p:tgtEl>
+                                        <p:attrNameLst>
+                                          <p:attrName>style.visibility</p:attrName>
+                                        </p:attrNameLst>
+                                      </p:cBhvr>
+                                      <p:to>
+                                        <p:strVal val="visible"/>
+                                      </p:to>
+                                    </p:set>
+                                  </p:childTnLst>
+                                </p:cTn>
+                              </p:par>
+                            </p:childTnLst>
+                          </p:cTn>
+                        </p:par>
+                      </p:childTnLst>
+                    </p:cTn>
+                  </p:par>
+                  <p:par>
+                    <p:cTn id="23" fill="hold">
+                      <p:stCondLst>
+                        <p:cond delay="indefinite"/>
+                      </p:stCondLst>
+                      <p:childTnLst>
+                        <p:par>
+                          <p:cTn id="24" fill="hold">
+                            <p:stCondLst>
+                              <p:cond delay="0"/>
+                            </p:stCondLst>
+                            <p:childTnLst>
+                              <p:par>
+                                <p:cTn id="25" presetID="1" presetClass="entr" presetSubtype="0" fill="hold" nodeType="clickEffect">
+                                  <p:stCondLst>
+                                    <p:cond delay="0"/>
+                                  </p:stCondLst>
+                                  <p:childTnLst>
+                                    <p:set>
+                                      <p:cBhvr>
+                                        <p:cTn id="26" dur="1" fill="hold">
+                                          <p:stCondLst>
+                                            <p:cond delay="0"/>
+                                          </p:stCondLst>
+                                        </p:cTn>
+                                        <p:tgtEl>
+                                          <p:spTgt spid="3">
+                                            <p:txEl>
+                                              <p:pRg st="14" end="14"/>
+                                            </p:txEl>
+                                          </p:spTgt>
+                                        </p:tgtEl>
+                                        <p:attrNameLst>
+                                          <p:attrName>style.visibility</p:attrName>
+                                        </p:attrNameLst>
+                                      </p:cBhvr>
+                                      <p:to>
+                                        <p:strVal val="visible"/>
+                                      </p:to>
+                                    </p:set>
+                                  </p:childTnLst>
+                                </p:cTn>
+                              </p:par>
+                              <p:par>
+                                <p:cTn id="27" presetID="1" presetClass="entr" presetSubtype="0" fill="hold" nodeType="withEffect">
+                                  <p:stCondLst>
+                                    <p:cond delay="0"/>
+                                  </p:stCondLst>
+                                  <p:childTnLst>
+                                    <p:set>
+                                      <p:cBhvr>
+                                        <p:cTn id="28" dur="1" fill="hold">
+                                          <p:stCondLst>
+                                            <p:cond delay="0"/>
+                                          </p:stCondLst>
+                                        </p:cTn>
+                                        <p:tgtEl>
+                                          <p:spTgt spid="3">
+                                            <p:txEl>
+                                              <p:pRg st="15" end="15"/>
+                                            </p:txEl>
+                                          </p:spTgt>
+                                        </p:tgtEl>
+                                        <p:attrNameLst>
+                                          <p:attrName>style.visibility</p:attrName>
+                                        </p:attrNameLst>
+                                      </p:cBhvr>
+                                      <p:to>
+                                        <p:strVal val="visible"/>
+                                      </p:to>
+                                    </p:set>
+                                  </p:childTnLst>
+                                </p:cTn>
+                              </p:par>
+                            </p:childTnLst>
+                          </p:cTn>
+                        </p:par>
+                      </p:childTnLst>
+                    </p:cTn>
+                  </p:par>
+                </p:childTnLst>
+              </p:cTn>
+              <p:prevCondLst>
+                <p:cond evt="onPrev" delay="0">
+                  <p:tgtEl>
+                    <p:sldTgt/>
+                  </p:tgtEl>
+                </p:cond>
+              </p:prevCondLst>
+              <p:nextCondLst>
+                <p:cond evt="onNext" delay="0">
+                  <p:tgtEl>
+                    <p:sldTgt/>
+                  </p:tgtEl>
+                </p:cond>
+              </p:nextCondLst>
+            </p:seq>
+          </p:childTnLst>
+        </p:cTn>
+      </p:par>
+    </p:tnLst>
+  </p:timing>
 </p:sld>
 </file>
 
@@ -18930,6 +19815,565 @@
   <p:clrMapOvr>
     <a:masterClrMapping/>
   </p:clrMapOvr>
+  <p:timing>
+    <p:tnLst>
+      <p:par>
+        <p:cTn id="1" dur="indefinite" restart="never" nodeType="tmRoot">
+          <p:childTnLst>
+            <p:seq concurrent="1" nextAc="seek">
+              <p:cTn id="2" dur="indefinite" nodeType="mainSeq">
+                <p:childTnLst>
+                  <p:par>
+                    <p:cTn id="3" fill="hold">
+                      <p:stCondLst>
+                        <p:cond delay="indefinite"/>
+                      </p:stCondLst>
+                      <p:childTnLst>
+                        <p:par>
+                          <p:cTn id="4" fill="hold">
+                            <p:stCondLst>
+                              <p:cond delay="0"/>
+                            </p:stCondLst>
+                            <p:childTnLst>
+                              <p:par>
+                                <p:cTn id="5" presetID="1" presetClass="entr" presetSubtype="0" fill="hold" nodeType="clickEffect">
+                                  <p:stCondLst>
+                                    <p:cond delay="0"/>
+                                  </p:stCondLst>
+                                  <p:childTnLst>
+                                    <p:set>
+                                      <p:cBhvr>
+                                        <p:cTn id="6" dur="1" fill="hold">
+                                          <p:stCondLst>
+                                            <p:cond delay="0"/>
+                                          </p:stCondLst>
+                                        </p:cTn>
+                                        <p:tgtEl>
+                                          <p:spTgt spid="3">
+                                            <p:txEl>
+                                              <p:pRg st="0" end="0"/>
+                                            </p:txEl>
+                                          </p:spTgt>
+                                        </p:tgtEl>
+                                        <p:attrNameLst>
+                                          <p:attrName>style.visibility</p:attrName>
+                                        </p:attrNameLst>
+                                      </p:cBhvr>
+                                      <p:to>
+                                        <p:strVal val="visible"/>
+                                      </p:to>
+                                    </p:set>
+                                  </p:childTnLst>
+                                </p:cTn>
+                              </p:par>
+                            </p:childTnLst>
+                          </p:cTn>
+                        </p:par>
+                      </p:childTnLst>
+                    </p:cTn>
+                  </p:par>
+                  <p:par>
+                    <p:cTn id="7" fill="hold">
+                      <p:stCondLst>
+                        <p:cond delay="indefinite"/>
+                      </p:stCondLst>
+                      <p:childTnLst>
+                        <p:par>
+                          <p:cTn id="8" fill="hold">
+                            <p:stCondLst>
+                              <p:cond delay="0"/>
+                            </p:stCondLst>
+                            <p:childTnLst>
+                              <p:par>
+                                <p:cTn id="9" presetID="1" presetClass="entr" presetSubtype="0" fill="hold" nodeType="clickEffect">
+                                  <p:stCondLst>
+                                    <p:cond delay="0"/>
+                                  </p:stCondLst>
+                                  <p:childTnLst>
+                                    <p:set>
+                                      <p:cBhvr>
+                                        <p:cTn id="10" dur="1" fill="hold">
+                                          <p:stCondLst>
+                                            <p:cond delay="0"/>
+                                          </p:stCondLst>
+                                        </p:cTn>
+                                        <p:tgtEl>
+                                          <p:spTgt spid="3">
+                                            <p:txEl>
+                                              <p:pRg st="2" end="2"/>
+                                            </p:txEl>
+                                          </p:spTgt>
+                                        </p:tgtEl>
+                                        <p:attrNameLst>
+                                          <p:attrName>style.visibility</p:attrName>
+                                        </p:attrNameLst>
+                                      </p:cBhvr>
+                                      <p:to>
+                                        <p:strVal val="visible"/>
+                                      </p:to>
+                                    </p:set>
+                                  </p:childTnLst>
+                                </p:cTn>
+                              </p:par>
+                              <p:par>
+                                <p:cTn id="11" presetID="1" presetClass="entr" presetSubtype="0" fill="hold" nodeType="withEffect">
+                                  <p:stCondLst>
+                                    <p:cond delay="0"/>
+                                  </p:stCondLst>
+                                  <p:childTnLst>
+                                    <p:set>
+                                      <p:cBhvr>
+                                        <p:cTn id="12" dur="1" fill="hold">
+                                          <p:stCondLst>
+                                            <p:cond delay="0"/>
+                                          </p:stCondLst>
+                                        </p:cTn>
+                                        <p:tgtEl>
+                                          <p:spTgt spid="3">
+                                            <p:txEl>
+                                              <p:pRg st="3" end="3"/>
+                                            </p:txEl>
+                                          </p:spTgt>
+                                        </p:tgtEl>
+                                        <p:attrNameLst>
+                                          <p:attrName>style.visibility</p:attrName>
+                                        </p:attrNameLst>
+                                      </p:cBhvr>
+                                      <p:to>
+                                        <p:strVal val="visible"/>
+                                      </p:to>
+                                    </p:set>
+                                  </p:childTnLst>
+                                </p:cTn>
+                              </p:par>
+                            </p:childTnLst>
+                          </p:cTn>
+                        </p:par>
+                      </p:childTnLst>
+                    </p:cTn>
+                  </p:par>
+                  <p:par>
+                    <p:cTn id="13" fill="hold">
+                      <p:stCondLst>
+                        <p:cond delay="indefinite"/>
+                      </p:stCondLst>
+                      <p:childTnLst>
+                        <p:par>
+                          <p:cTn id="14" fill="hold">
+                            <p:stCondLst>
+                              <p:cond delay="0"/>
+                            </p:stCondLst>
+                            <p:childTnLst>
+                              <p:par>
+                                <p:cTn id="15" presetID="1" presetClass="entr" presetSubtype="0" fill="hold" nodeType="clickEffect">
+                                  <p:stCondLst>
+                                    <p:cond delay="0"/>
+                                  </p:stCondLst>
+                                  <p:childTnLst>
+                                    <p:set>
+                                      <p:cBhvr>
+                                        <p:cTn id="16" dur="1" fill="hold">
+                                          <p:stCondLst>
+                                            <p:cond delay="0"/>
+                                          </p:stCondLst>
+                                        </p:cTn>
+                                        <p:tgtEl>
+                                          <p:spTgt spid="3">
+                                            <p:txEl>
+                                              <p:pRg st="5" end="5"/>
+                                            </p:txEl>
+                                          </p:spTgt>
+                                        </p:tgtEl>
+                                        <p:attrNameLst>
+                                          <p:attrName>style.visibility</p:attrName>
+                                        </p:attrNameLst>
+                                      </p:cBhvr>
+                                      <p:to>
+                                        <p:strVal val="visible"/>
+                                      </p:to>
+                                    </p:set>
+                                  </p:childTnLst>
+                                </p:cTn>
+                              </p:par>
+                              <p:par>
+                                <p:cTn id="17" presetID="1" presetClass="entr" presetSubtype="0" fill="hold" nodeType="withEffect">
+                                  <p:stCondLst>
+                                    <p:cond delay="0"/>
+                                  </p:stCondLst>
+                                  <p:childTnLst>
+                                    <p:set>
+                                      <p:cBhvr>
+                                        <p:cTn id="18" dur="1" fill="hold">
+                                          <p:stCondLst>
+                                            <p:cond delay="0"/>
+                                          </p:stCondLst>
+                                        </p:cTn>
+                                        <p:tgtEl>
+                                          <p:spTgt spid="3">
+                                            <p:txEl>
+                                              <p:pRg st="6" end="6"/>
+                                            </p:txEl>
+                                          </p:spTgt>
+                                        </p:tgtEl>
+                                        <p:attrNameLst>
+                                          <p:attrName>style.visibility</p:attrName>
+                                        </p:attrNameLst>
+                                      </p:cBhvr>
+                                      <p:to>
+                                        <p:strVal val="visible"/>
+                                      </p:to>
+                                    </p:set>
+                                  </p:childTnLst>
+                                </p:cTn>
+                              </p:par>
+                            </p:childTnLst>
+                          </p:cTn>
+                        </p:par>
+                      </p:childTnLst>
+                    </p:cTn>
+                  </p:par>
+                  <p:par>
+                    <p:cTn id="19" fill="hold">
+                      <p:stCondLst>
+                        <p:cond delay="indefinite"/>
+                      </p:stCondLst>
+                      <p:childTnLst>
+                        <p:par>
+                          <p:cTn id="20" fill="hold">
+                            <p:stCondLst>
+                              <p:cond delay="0"/>
+                            </p:stCondLst>
+                            <p:childTnLst>
+                              <p:par>
+                                <p:cTn id="21" presetID="1" presetClass="entr" presetSubtype="0" fill="hold" nodeType="clickEffect">
+                                  <p:stCondLst>
+                                    <p:cond delay="0"/>
+                                  </p:stCondLst>
+                                  <p:childTnLst>
+                                    <p:set>
+                                      <p:cBhvr>
+                                        <p:cTn id="22" dur="1" fill="hold">
+                                          <p:stCondLst>
+                                            <p:cond delay="0"/>
+                                          </p:stCondLst>
+                                        </p:cTn>
+                                        <p:tgtEl>
+                                          <p:spTgt spid="3">
+                                            <p:txEl>
+                                              <p:pRg st="8" end="8"/>
+                                            </p:txEl>
+                                          </p:spTgt>
+                                        </p:tgtEl>
+                                        <p:attrNameLst>
+                                          <p:attrName>style.visibility</p:attrName>
+                                        </p:attrNameLst>
+                                      </p:cBhvr>
+                                      <p:to>
+                                        <p:strVal val="visible"/>
+                                      </p:to>
+                                    </p:set>
+                                  </p:childTnLst>
+                                </p:cTn>
+                              </p:par>
+                              <p:par>
+                                <p:cTn id="23" presetID="1" presetClass="entr" presetSubtype="0" fill="hold" nodeType="withEffect">
+                                  <p:stCondLst>
+                                    <p:cond delay="0"/>
+                                  </p:stCondLst>
+                                  <p:childTnLst>
+                                    <p:set>
+                                      <p:cBhvr>
+                                        <p:cTn id="24" dur="1" fill="hold">
+                                          <p:stCondLst>
+                                            <p:cond delay="0"/>
+                                          </p:stCondLst>
+                                        </p:cTn>
+                                        <p:tgtEl>
+                                          <p:spTgt spid="3">
+                                            <p:txEl>
+                                              <p:pRg st="9" end="9"/>
+                                            </p:txEl>
+                                          </p:spTgt>
+                                        </p:tgtEl>
+                                        <p:attrNameLst>
+                                          <p:attrName>style.visibility</p:attrName>
+                                        </p:attrNameLst>
+                                      </p:cBhvr>
+                                      <p:to>
+                                        <p:strVal val="visible"/>
+                                      </p:to>
+                                    </p:set>
+                                  </p:childTnLst>
+                                </p:cTn>
+                              </p:par>
+                            </p:childTnLst>
+                          </p:cTn>
+                        </p:par>
+                      </p:childTnLst>
+                    </p:cTn>
+                  </p:par>
+                  <p:par>
+                    <p:cTn id="25" fill="hold">
+                      <p:stCondLst>
+                        <p:cond delay="indefinite"/>
+                      </p:stCondLst>
+                      <p:childTnLst>
+                        <p:par>
+                          <p:cTn id="26" fill="hold">
+                            <p:stCondLst>
+                              <p:cond delay="0"/>
+                            </p:stCondLst>
+                            <p:childTnLst>
+                              <p:par>
+                                <p:cTn id="27" presetID="1" presetClass="entr" presetSubtype="0" fill="hold" nodeType="clickEffect">
+                                  <p:stCondLst>
+                                    <p:cond delay="0"/>
+                                  </p:stCondLst>
+                                  <p:childTnLst>
+                                    <p:set>
+                                      <p:cBhvr>
+                                        <p:cTn id="28" dur="1" fill="hold">
+                                          <p:stCondLst>
+                                            <p:cond delay="0"/>
+                                          </p:stCondLst>
+                                        </p:cTn>
+                                        <p:tgtEl>
+                                          <p:spTgt spid="3">
+                                            <p:txEl>
+                                              <p:pRg st="11" end="11"/>
+                                            </p:txEl>
+                                          </p:spTgt>
+                                        </p:tgtEl>
+                                        <p:attrNameLst>
+                                          <p:attrName>style.visibility</p:attrName>
+                                        </p:attrNameLst>
+                                      </p:cBhvr>
+                                      <p:to>
+                                        <p:strVal val="visible"/>
+                                      </p:to>
+                                    </p:set>
+                                  </p:childTnLst>
+                                </p:cTn>
+                              </p:par>
+                              <p:par>
+                                <p:cTn id="29" presetID="1" presetClass="entr" presetSubtype="0" fill="hold" nodeType="withEffect">
+                                  <p:stCondLst>
+                                    <p:cond delay="0"/>
+                                  </p:stCondLst>
+                                  <p:childTnLst>
+                                    <p:set>
+                                      <p:cBhvr>
+                                        <p:cTn id="30" dur="1" fill="hold">
+                                          <p:stCondLst>
+                                            <p:cond delay="0"/>
+                                          </p:stCondLst>
+                                        </p:cTn>
+                                        <p:tgtEl>
+                                          <p:spTgt spid="3">
+                                            <p:txEl>
+                                              <p:pRg st="12" end="12"/>
+                                            </p:txEl>
+                                          </p:spTgt>
+                                        </p:tgtEl>
+                                        <p:attrNameLst>
+                                          <p:attrName>style.visibility</p:attrName>
+                                        </p:attrNameLst>
+                                      </p:cBhvr>
+                                      <p:to>
+                                        <p:strVal val="visible"/>
+                                      </p:to>
+                                    </p:set>
+                                  </p:childTnLst>
+                                </p:cTn>
+                              </p:par>
+                            </p:childTnLst>
+                          </p:cTn>
+                        </p:par>
+                      </p:childTnLst>
+                    </p:cTn>
+                  </p:par>
+                  <p:par>
+                    <p:cTn id="31" fill="hold">
+                      <p:stCondLst>
+                        <p:cond delay="indefinite"/>
+                      </p:stCondLst>
+                      <p:childTnLst>
+                        <p:par>
+                          <p:cTn id="32" fill="hold">
+                            <p:stCondLst>
+                              <p:cond delay="0"/>
+                            </p:stCondLst>
+                            <p:childTnLst>
+                              <p:par>
+                                <p:cTn id="33" presetID="1" presetClass="entr" presetSubtype="0" fill="hold" nodeType="clickEffect">
+                                  <p:stCondLst>
+                                    <p:cond delay="0"/>
+                                  </p:stCondLst>
+                                  <p:childTnLst>
+                                    <p:set>
+                                      <p:cBhvr>
+                                        <p:cTn id="34" dur="1" fill="hold">
+                                          <p:stCondLst>
+                                            <p:cond delay="0"/>
+                                          </p:stCondLst>
+                                        </p:cTn>
+                                        <p:tgtEl>
+                                          <p:spTgt spid="3">
+                                            <p:txEl>
+                                              <p:pRg st="14" end="14"/>
+                                            </p:txEl>
+                                          </p:spTgt>
+                                        </p:tgtEl>
+                                        <p:attrNameLst>
+                                          <p:attrName>style.visibility</p:attrName>
+                                        </p:attrNameLst>
+                                      </p:cBhvr>
+                                      <p:to>
+                                        <p:strVal val="visible"/>
+                                      </p:to>
+                                    </p:set>
+                                  </p:childTnLst>
+                                </p:cTn>
+                              </p:par>
+                              <p:par>
+                                <p:cTn id="35" presetID="1" presetClass="entr" presetSubtype="0" fill="hold" nodeType="withEffect">
+                                  <p:stCondLst>
+                                    <p:cond delay="0"/>
+                                  </p:stCondLst>
+                                  <p:childTnLst>
+                                    <p:set>
+                                      <p:cBhvr>
+                                        <p:cTn id="36" dur="1" fill="hold">
+                                          <p:stCondLst>
+                                            <p:cond delay="0"/>
+                                          </p:stCondLst>
+                                        </p:cTn>
+                                        <p:tgtEl>
+                                          <p:spTgt spid="3">
+                                            <p:txEl>
+                                              <p:pRg st="15" end="15"/>
+                                            </p:txEl>
+                                          </p:spTgt>
+                                        </p:tgtEl>
+                                        <p:attrNameLst>
+                                          <p:attrName>style.visibility</p:attrName>
+                                        </p:attrNameLst>
+                                      </p:cBhvr>
+                                      <p:to>
+                                        <p:strVal val="visible"/>
+                                      </p:to>
+                                    </p:set>
+                                  </p:childTnLst>
+                                </p:cTn>
+                              </p:par>
+                            </p:childTnLst>
+                          </p:cTn>
+                        </p:par>
+                      </p:childTnLst>
+                    </p:cTn>
+                  </p:par>
+                  <p:par>
+                    <p:cTn id="37" fill="hold">
+                      <p:stCondLst>
+                        <p:cond delay="indefinite"/>
+                      </p:stCondLst>
+                      <p:childTnLst>
+                        <p:par>
+                          <p:cTn id="38" fill="hold">
+                            <p:stCondLst>
+                              <p:cond delay="0"/>
+                            </p:stCondLst>
+                            <p:childTnLst>
+                              <p:par>
+                                <p:cTn id="39" presetID="1" presetClass="entr" presetSubtype="0" fill="hold" nodeType="clickEffect">
+                                  <p:stCondLst>
+                                    <p:cond delay="0"/>
+                                  </p:stCondLst>
+                                  <p:childTnLst>
+                                    <p:set>
+                                      <p:cBhvr>
+                                        <p:cTn id="40" dur="1" fill="hold">
+                                          <p:stCondLst>
+                                            <p:cond delay="0"/>
+                                          </p:stCondLst>
+                                        </p:cTn>
+                                        <p:tgtEl>
+                                          <p:spTgt spid="3">
+                                            <p:txEl>
+                                              <p:pRg st="17" end="17"/>
+                                            </p:txEl>
+                                          </p:spTgt>
+                                        </p:tgtEl>
+                                        <p:attrNameLst>
+                                          <p:attrName>style.visibility</p:attrName>
+                                        </p:attrNameLst>
+                                      </p:cBhvr>
+                                      <p:to>
+                                        <p:strVal val="visible"/>
+                                      </p:to>
+                                    </p:set>
+                                  </p:childTnLst>
+                                </p:cTn>
+                              </p:par>
+                              <p:par>
+                                <p:cTn id="41" presetID="1" presetClass="entr" presetSubtype="0" fill="hold" nodeType="withEffect">
+                                  <p:stCondLst>
+                                    <p:cond delay="0"/>
+                                  </p:stCondLst>
+                                  <p:childTnLst>
+                                    <p:set>
+                                      <p:cBhvr>
+                                        <p:cTn id="42" dur="1" fill="hold">
+                                          <p:stCondLst>
+                                            <p:cond delay="0"/>
+                                          </p:stCondLst>
+                                        </p:cTn>
+                                        <p:tgtEl>
+                                          <p:spTgt spid="3">
+                                            <p:txEl>
+                                              <p:pRg st="18" end="18"/>
+                                            </p:txEl>
+                                          </p:spTgt>
+                                        </p:tgtEl>
+                                        <p:attrNameLst>
+                                          <p:attrName>style.visibility</p:attrName>
+                                        </p:attrNameLst>
+                                      </p:cBhvr>
+                                      <p:to>
+                                        <p:strVal val="visible"/>
+                                      </p:to>
+                                    </p:set>
+                                  </p:childTnLst>
+                                </p:cTn>
+                              </p:par>
+                            </p:childTnLst>
+                          </p:cTn>
+                        </p:par>
+                      </p:childTnLst>
+                    </p:cTn>
+                  </p:par>
+                </p:childTnLst>
+              </p:cTn>
+              <p:prevCondLst>
+                <p:cond evt="onPrev" delay="0">
+                  <p:tgtEl>
+                    <p:sldTgt/>
+                  </p:tgtEl>
+                </p:cond>
+              </p:prevCondLst>
+              <p:nextCondLst>
+                <p:cond evt="onNext" delay="0">
+                  <p:tgtEl>
+                    <p:sldTgt/>
+                  </p:tgtEl>
+                </p:cond>
+              </p:nextCondLst>
+            </p:seq>
+          </p:childTnLst>
+        </p:cTn>
+      </p:par>
+    </p:tnLst>
+  </p:timing>
 </p:sld>
 </file>
 

</xml_diff>